<commit_message>
Update academic slide minimalist skill
</commit_message>
<xml_diff>
--- a/academic-slide-minimalist/assets/sample-literature-report.pptx
+++ b/academic-slide-minimalist/assets/sample-literature-report.pptx
@@ -1667,7 +1667,7 @@
           <a:p>
             <a:fld id="{A4E86590-90B0-4030-8A0F-1ECD38F1582E}" type="datetimeFigureOut">
               <a:rPr lang="zh-CN" altLang="en-US" smtClean="0"/>
-              <a:t>2026/5/19</a:t>
+              <a:t>2026/4/25</a:t>
             </a:fld>
             <a:endParaRPr lang="zh-CN" altLang="en-US"/>
           </a:p>
@@ -2065,7 +2065,7 @@
           <a:p>
             <a:fld id="{A4E86590-90B0-4030-8A0F-1ECD38F1582E}" type="datetimeFigureOut">
               <a:rPr lang="zh-CN" altLang="en-US" smtClean="0"/>
-              <a:t>2026/5/19</a:t>
+              <a:t>2026/4/25</a:t>
             </a:fld>
             <a:endParaRPr lang="zh-CN" altLang="en-US"/>
           </a:p>
@@ -2209,7 +2209,7 @@
           <a:p>
             <a:fld id="{A4E86590-90B0-4030-8A0F-1ECD38F1582E}" type="datetimeFigureOut">
               <a:rPr lang="zh-CN" altLang="en-US" smtClean="0"/>
-              <a:t>2026/5/19</a:t>
+              <a:t>2026/4/25</a:t>
             </a:fld>
             <a:endParaRPr lang="zh-CN" altLang="en-US"/>
           </a:p>
@@ -2323,7 +2323,7 @@
           <a:p>
             <a:fld id="{A4E86590-90B0-4030-8A0F-1ECD38F1582E}" type="datetimeFigureOut">
               <a:rPr lang="zh-CN" altLang="en-US" smtClean="0"/>
-              <a:t>2026/5/19</a:t>
+              <a:t>2026/4/25</a:t>
             </a:fld>
             <a:endParaRPr lang="zh-CN" altLang="en-US"/>
           </a:p>
@@ -2626,7 +2626,7 @@
           <a:p>
             <a:fld id="{A4E86590-90B0-4030-8A0F-1ECD38F1582E}" type="datetimeFigureOut">
               <a:rPr lang="zh-CN" altLang="en-US" smtClean="0"/>
-              <a:t>2026/5/19</a:t>
+              <a:t>2026/4/25</a:t>
             </a:fld>
             <a:endParaRPr lang="zh-CN" altLang="en-US"/>
           </a:p>
@@ -2906,7 +2906,7 @@
           <a:p>
             <a:fld id="{A4E86590-90B0-4030-8A0F-1ECD38F1582E}" type="datetimeFigureOut">
               <a:rPr lang="zh-CN" altLang="en-US" smtClean="0"/>
-              <a:t>2026/5/19</a:t>
+              <a:t>2026/4/25</a:t>
             </a:fld>
             <a:endParaRPr lang="zh-CN" altLang="en-US"/>
           </a:p>
@@ -3134,7 +3134,7 @@
           <a:p>
             <a:fld id="{A4E86590-90B0-4030-8A0F-1ECD38F1582E}" type="datetimeFigureOut">
               <a:rPr lang="zh-CN" altLang="en-US" smtClean="0"/>
-              <a:t>2026/5/19</a:t>
+              <a:t>2026/4/25</a:t>
             </a:fld>
             <a:endParaRPr lang="zh-CN" altLang="en-US"/>
           </a:p>
@@ -3337,7 +3337,7 @@
           <a:p>
             <a:fld id="{A4E86590-90B0-4030-8A0F-1ECD38F1582E}" type="datetimeFigureOut">
               <a:rPr lang="zh-CN" altLang="en-US" smtClean="0"/>
-              <a:t>2026/5/19</a:t>
+              <a:t>2026/4/25</a:t>
             </a:fld>
             <a:endParaRPr lang="zh-CN" altLang="en-US"/>
           </a:p>
@@ -3468,7 +3468,7 @@
           <a:p>
             <a:fld id="{B600928E-9ACF-41AC-9CC3-03BBBBBCD0E0}" type="datetimeFigureOut">
               <a:rPr lang="zh-CN" altLang="en-US" smtClean="0"/>
-              <a:t>2026/5/19</a:t>
+              <a:t>2026/4/25</a:t>
             </a:fld>
             <a:endParaRPr lang="zh-CN" altLang="en-US"/>
           </a:p>
@@ -8980,7 +8980,7 @@
                 <a:latin typeface="微软雅黑" panose="020B0503020204020204" charset="-122"/>
                 <a:ea typeface="微软雅黑" panose="020B0503020204020204" charset="-122"/>
               </a:rPr>
-              <a:t>汇报人：xxx</a:t>
+              <a:t>汇报人：苏俊朋</a:t>
             </a:r>
             <a:endParaRPr lang="en-US" altLang="zh-CN" sz="2400" b="1" dirty="0">
               <a:latin typeface="微软雅黑" panose="020B0503020204020204" charset="-122"/>

</xml_diff>